<commit_message>
Added Auto-injector project, updated naming
Updated all projects. Most notably, added a project between the old projects 1 and 2. The old project 2 (Bobblestat) is now project 3. The new project 2 is auto-injector. I am still figuring out how to present the flow simulation findings. Otherwise, just changes to make increase clarity and address typos.
</commit_message>
<xml_diff>
--- a/Project1_SolidWorks_Portable_Testing_Chamber/Project1_Portable_Testing_Chamber_Overview.pptx
+++ b/Project1_SolidWorks_Portable_Testing_Chamber/Project1_Portable_Testing_Chamber_Overview.pptx
@@ -12,6 +12,7 @@
     <p:sldId id="261" r:id="rId6"/>
     <p:sldId id="259" r:id="rId7"/>
     <p:sldId id="263" r:id="rId8"/>
+    <p:sldId id="269" r:id="rId9"/>
   </p:sldIdLst>
   <p:sldSz cx="12192000" cy="6858000"/>
   <p:notesSz cx="6858000" cy="9144000"/>
@@ -121,8 +122,7 @@
 <file path=ppt/revisionInfo.xml><?xml version="1.0" encoding="utf-8"?>
 <p1510:revInfo xmlns:a="http://schemas.openxmlformats.org/drawingml/2006/main" xmlns:r="http://schemas.openxmlformats.org/officeDocument/2006/relationships" xmlns:p1510="http://schemas.microsoft.com/office/powerpoint/2015/10/main">
   <p1510:revLst>
-    <p1510:client id="{412694EA-A4F6-4591-A250-A3EC668234F7}" v="2" dt="2025-05-21T06:12:13.334"/>
-    <p1510:client id="{5D971BBD-9865-41A7-A526-B0C275857285}" v="114" dt="2025-05-22T02:14:14.598"/>
+    <p1510:client id="{1906F399-60B4-4E8B-9F16-D0F5171D0160}" v="5" dt="2025-06-04T18:23:25.028"/>
   </p1510:revLst>
 </p1510:revInfo>
 </file>
@@ -165,14 +165,6 @@
           <pc:docMk/>
           <pc:sldMk cId="1533612860" sldId="257"/>
         </pc:sldMkLst>
-        <pc:spChg chg="mod">
-          <ac:chgData name="Jason Chen" userId="ad652ca3-8ddd-474a-8ac5-da1049da0a80" providerId="ADAL" clId="{412694EA-A4F6-4591-A250-A3EC668234F7}" dt="2025-05-21T05:27:32.860" v="84" actId="20577"/>
-          <ac:spMkLst>
-            <pc:docMk/>
-            <pc:sldMk cId="1533612860" sldId="257"/>
-            <ac:spMk id="2" creationId="{FB3CB31C-3DE0-6912-9DB9-3EE1697969B1}"/>
-          </ac:spMkLst>
-        </pc:spChg>
       </pc:sldChg>
       <pc:sldChg chg="addSp delSp modSp new mod">
         <pc:chgData name="Jason Chen" userId="ad652ca3-8ddd-474a-8ac5-da1049da0a80" providerId="ADAL" clId="{412694EA-A4F6-4591-A250-A3EC668234F7}" dt="2025-05-21T06:19:17.227" v="403" actId="1076"/>
@@ -186,14 +178,6 @@
             <pc:docMk/>
             <pc:sldMk cId="1797865909" sldId="258"/>
             <ac:spMk id="2" creationId="{E1AA93DD-AA45-3DB9-3DE2-D522104C483B}"/>
-          </ac:spMkLst>
-        </pc:spChg>
-        <pc:spChg chg="del mod">
-          <ac:chgData name="Jason Chen" userId="ad652ca3-8ddd-474a-8ac5-da1049da0a80" providerId="ADAL" clId="{412694EA-A4F6-4591-A250-A3EC668234F7}" dt="2025-05-21T06:12:13.334" v="391" actId="931"/>
-          <ac:spMkLst>
-            <pc:docMk/>
-            <pc:sldMk cId="1797865909" sldId="258"/>
-            <ac:spMk id="3" creationId="{2DB7E31C-5E4F-64DE-91E5-56C6641A89DC}"/>
           </ac:spMkLst>
         </pc:spChg>
         <pc:picChg chg="add mod modCrop">
@@ -226,94 +210,6 @@
           <pc:docMk/>
           <pc:sldMk cId="593649283" sldId="260"/>
         </pc:sldMkLst>
-        <pc:spChg chg="del">
-          <ac:chgData name="Jason Chen" userId="ad652ca3-8ddd-474a-8ac5-da1049da0a80" providerId="ADAL" clId="{412694EA-A4F6-4591-A250-A3EC668234F7}" dt="2025-05-21T05:35:04.615" v="135" actId="478"/>
-          <ac:spMkLst>
-            <pc:docMk/>
-            <pc:sldMk cId="593649283" sldId="260"/>
-            <ac:spMk id="3" creationId="{BB930191-BCDC-85C1-D0C6-96B9FBB3B13B}"/>
-          </ac:spMkLst>
-        </pc:spChg>
-        <pc:spChg chg="add mod">
-          <ac:chgData name="Jason Chen" userId="ad652ca3-8ddd-474a-8ac5-da1049da0a80" providerId="ADAL" clId="{412694EA-A4F6-4591-A250-A3EC668234F7}" dt="2025-05-21T05:34:59.407" v="134"/>
-          <ac:spMkLst>
-            <pc:docMk/>
-            <pc:sldMk cId="593649283" sldId="260"/>
-            <ac:spMk id="4" creationId="{51DB267E-F4D0-5DB8-68AB-86A2980B7383}"/>
-          </ac:spMkLst>
-        </pc:spChg>
-        <pc:spChg chg="add mod">
-          <ac:chgData name="Jason Chen" userId="ad652ca3-8ddd-474a-8ac5-da1049da0a80" providerId="ADAL" clId="{412694EA-A4F6-4591-A250-A3EC668234F7}" dt="2025-05-21T05:34:59.407" v="134"/>
-          <ac:spMkLst>
-            <pc:docMk/>
-            <pc:sldMk cId="593649283" sldId="260"/>
-            <ac:spMk id="5" creationId="{56661385-3350-325D-7489-48C8389A4E47}"/>
-          </ac:spMkLst>
-        </pc:spChg>
-        <pc:spChg chg="add mod">
-          <ac:chgData name="Jason Chen" userId="ad652ca3-8ddd-474a-8ac5-da1049da0a80" providerId="ADAL" clId="{412694EA-A4F6-4591-A250-A3EC668234F7}" dt="2025-05-21T05:34:59.407" v="134"/>
-          <ac:spMkLst>
-            <pc:docMk/>
-            <pc:sldMk cId="593649283" sldId="260"/>
-            <ac:spMk id="6" creationId="{FCB7841A-31E4-5B84-9779-DF3F896C4E91}"/>
-          </ac:spMkLst>
-        </pc:spChg>
-        <pc:spChg chg="add mod">
-          <ac:chgData name="Jason Chen" userId="ad652ca3-8ddd-474a-8ac5-da1049da0a80" providerId="ADAL" clId="{412694EA-A4F6-4591-A250-A3EC668234F7}" dt="2025-05-21T05:34:59.407" v="134"/>
-          <ac:spMkLst>
-            <pc:docMk/>
-            <pc:sldMk cId="593649283" sldId="260"/>
-            <ac:spMk id="7" creationId="{7DE56287-2840-0C30-ACAD-E2E0F8536CE1}"/>
-          </ac:spMkLst>
-        </pc:spChg>
-        <pc:spChg chg="add mod">
-          <ac:chgData name="Jason Chen" userId="ad652ca3-8ddd-474a-8ac5-da1049da0a80" providerId="ADAL" clId="{412694EA-A4F6-4591-A250-A3EC668234F7}" dt="2025-05-21T05:34:59.407" v="134"/>
-          <ac:spMkLst>
-            <pc:docMk/>
-            <pc:sldMk cId="593649283" sldId="260"/>
-            <ac:spMk id="8" creationId="{7A0E25EE-9EFA-F90E-39BD-ED71346E0850}"/>
-          </ac:spMkLst>
-        </pc:spChg>
-        <pc:spChg chg="add mod">
-          <ac:chgData name="Jason Chen" userId="ad652ca3-8ddd-474a-8ac5-da1049da0a80" providerId="ADAL" clId="{412694EA-A4F6-4591-A250-A3EC668234F7}" dt="2025-05-21T05:34:59.407" v="134"/>
-          <ac:spMkLst>
-            <pc:docMk/>
-            <pc:sldMk cId="593649283" sldId="260"/>
-            <ac:spMk id="9" creationId="{8CCC525C-1663-275A-9762-6A26449D47BC}"/>
-          </ac:spMkLst>
-        </pc:spChg>
-        <pc:spChg chg="add mod">
-          <ac:chgData name="Jason Chen" userId="ad652ca3-8ddd-474a-8ac5-da1049da0a80" providerId="ADAL" clId="{412694EA-A4F6-4591-A250-A3EC668234F7}" dt="2025-05-21T05:34:59.407" v="134"/>
-          <ac:spMkLst>
-            <pc:docMk/>
-            <pc:sldMk cId="593649283" sldId="260"/>
-            <ac:spMk id="10" creationId="{955264C6-5300-6E17-92A0-BB5C3BDFF765}"/>
-          </ac:spMkLst>
-        </pc:spChg>
-        <pc:spChg chg="add mod">
-          <ac:chgData name="Jason Chen" userId="ad652ca3-8ddd-474a-8ac5-da1049da0a80" providerId="ADAL" clId="{412694EA-A4F6-4591-A250-A3EC668234F7}" dt="2025-05-21T05:34:59.407" v="134"/>
-          <ac:spMkLst>
-            <pc:docMk/>
-            <pc:sldMk cId="593649283" sldId="260"/>
-            <ac:spMk id="11" creationId="{EFDC01DB-1140-64F6-0608-4D3F9DA9BF79}"/>
-          </ac:spMkLst>
-        </pc:spChg>
-        <pc:spChg chg="add mod">
-          <ac:chgData name="Jason Chen" userId="ad652ca3-8ddd-474a-8ac5-da1049da0a80" providerId="ADAL" clId="{412694EA-A4F6-4591-A250-A3EC668234F7}" dt="2025-05-21T05:34:59.407" v="134"/>
-          <ac:spMkLst>
-            <pc:docMk/>
-            <pc:sldMk cId="593649283" sldId="260"/>
-            <ac:spMk id="12" creationId="{D0AC5907-3920-19F0-8BA7-34D58D51CD3F}"/>
-          </ac:spMkLst>
-        </pc:spChg>
-        <pc:cxnChg chg="add mod">
-          <ac:chgData name="Jason Chen" userId="ad652ca3-8ddd-474a-8ac5-da1049da0a80" providerId="ADAL" clId="{412694EA-A4F6-4591-A250-A3EC668234F7}" dt="2025-05-21T05:34:59.407" v="134"/>
-          <ac:cxnSpMkLst>
-            <pc:docMk/>
-            <pc:sldMk cId="593649283" sldId="260"/>
-            <ac:cxnSpMk id="20" creationId="{CD0372BE-CBF7-A9C7-E7D6-84C031A7B876}"/>
-          </ac:cxnSpMkLst>
-        </pc:cxnChg>
       </pc:sldChg>
       <pc:sldChg chg="addSp modSp new mod">
         <pc:chgData name="Jason Chen" userId="ad652ca3-8ddd-474a-8ac5-da1049da0a80" providerId="ADAL" clId="{412694EA-A4F6-4591-A250-A3EC668234F7}" dt="2025-05-21T06:00:15.810" v="381" actId="14100"/>
@@ -343,6 +239,53 @@
             <pc:docMk/>
             <pc:sldMk cId="3879163758" sldId="261"/>
             <ac:picMk id="5" creationId="{8D280B7F-F25A-0E16-9516-CF8AC4ACA6E9}"/>
+          </ac:picMkLst>
+        </pc:picChg>
+      </pc:sldChg>
+    </pc:docChg>
+  </pc:docChgLst>
+  <pc:docChgLst>
+    <pc:chgData name="Jason Chen" userId="ad652ca3-8ddd-474a-8ac5-da1049da0a80" providerId="ADAL" clId="{1906F399-60B4-4E8B-9F16-D0F5171D0160}"/>
+    <pc:docChg chg="addSld delSld modSld">
+      <pc:chgData name="Jason Chen" userId="ad652ca3-8ddd-474a-8ac5-da1049da0a80" providerId="ADAL" clId="{1906F399-60B4-4E8B-9F16-D0F5171D0160}" dt="2025-06-04T18:24:44.305" v="127" actId="1076"/>
+      <pc:docMkLst>
+        <pc:docMk/>
+      </pc:docMkLst>
+      <pc:sldChg chg="new del">
+        <pc:chgData name="Jason Chen" userId="ad652ca3-8ddd-474a-8ac5-da1049da0a80" providerId="ADAL" clId="{1906F399-60B4-4E8B-9F16-D0F5171D0160}" dt="2025-06-04T18:21:25.635" v="2" actId="47"/>
+        <pc:sldMkLst>
+          <pc:docMk/>
+          <pc:sldMk cId="777982469" sldId="266"/>
+        </pc:sldMkLst>
+      </pc:sldChg>
+      <pc:sldChg chg="addSp delSp modSp add mod modAnim">
+        <pc:chgData name="Jason Chen" userId="ad652ca3-8ddd-474a-8ac5-da1049da0a80" providerId="ADAL" clId="{1906F399-60B4-4E8B-9F16-D0F5171D0160}" dt="2025-06-04T18:24:44.305" v="127" actId="1076"/>
+        <pc:sldMkLst>
+          <pc:docMk/>
+          <pc:sldMk cId="645902538" sldId="269"/>
+        </pc:sldMkLst>
+        <pc:spChg chg="del">
+          <ac:chgData name="Jason Chen" userId="ad652ca3-8ddd-474a-8ac5-da1049da0a80" providerId="ADAL" clId="{1906F399-60B4-4E8B-9F16-D0F5171D0160}" dt="2025-06-04T18:21:42.933" v="3"/>
+          <ac:spMkLst>
+            <pc:docMk/>
+            <pc:sldMk cId="645902538" sldId="269"/>
+            <ac:spMk id="3" creationId="{663782B0-1F97-78C5-236D-59305547980C}"/>
+          </ac:spMkLst>
+        </pc:spChg>
+        <pc:spChg chg="add mod">
+          <ac:chgData name="Jason Chen" userId="ad652ca3-8ddd-474a-8ac5-da1049da0a80" providerId="ADAL" clId="{1906F399-60B4-4E8B-9F16-D0F5171D0160}" dt="2025-06-04T18:24:35.065" v="125" actId="14100"/>
+          <ac:spMkLst>
+            <pc:docMk/>
+            <pc:sldMk cId="645902538" sldId="269"/>
+            <ac:spMk id="5" creationId="{A8310154-AB87-CD2F-41DF-CDD3C3C67B45}"/>
+          </ac:spMkLst>
+        </pc:spChg>
+        <pc:picChg chg="add mod">
+          <ac:chgData name="Jason Chen" userId="ad652ca3-8ddd-474a-8ac5-da1049da0a80" providerId="ADAL" clId="{1906F399-60B4-4E8B-9F16-D0F5171D0160}" dt="2025-06-04T18:24:44.305" v="127" actId="1076"/>
+          <ac:picMkLst>
+            <pc:docMk/>
+            <pc:sldMk cId="645902538" sldId="269"/>
+            <ac:picMk id="4" creationId="{69EB121A-51C7-D7E9-C237-A9C100B171E9}"/>
           </ac:picMkLst>
         </pc:picChg>
       </pc:sldChg>
@@ -384,22 +327,6 @@
           <pc:docMk/>
           <pc:sldMk cId="1533612860" sldId="257"/>
         </pc:sldMkLst>
-        <pc:spChg chg="mod">
-          <ac:chgData name="Jason Chen" userId="ad652ca3-8ddd-474a-8ac5-da1049da0a80" providerId="ADAL" clId="{5D971BBD-9865-41A7-A526-B0C275857285}" dt="2025-05-21T18:32:35.871" v="17" actId="21"/>
-          <ac:spMkLst>
-            <pc:docMk/>
-            <pc:sldMk cId="1533612860" sldId="257"/>
-            <ac:spMk id="2" creationId="{FB3CB31C-3DE0-6912-9DB9-3EE1697969B1}"/>
-          </ac:spMkLst>
-        </pc:spChg>
-        <pc:spChg chg="mod">
-          <ac:chgData name="Jason Chen" userId="ad652ca3-8ddd-474a-8ac5-da1049da0a80" providerId="ADAL" clId="{5D971BBD-9865-41A7-A526-B0C275857285}" dt="2025-05-21T18:32:23.800" v="12" actId="20577"/>
-          <ac:spMkLst>
-            <pc:docMk/>
-            <pc:sldMk cId="1533612860" sldId="257"/>
-            <ac:spMk id="3" creationId="{303AC3B6-ACAD-FFEF-AC49-7BA5C8E2275C}"/>
-          </ac:spMkLst>
-        </pc:spChg>
       </pc:sldChg>
       <pc:sldChg chg="addSp delSp modSp mod">
         <pc:chgData name="Jason Chen" userId="ad652ca3-8ddd-474a-8ac5-da1049da0a80" providerId="ADAL" clId="{5D971BBD-9865-41A7-A526-B0C275857285}" dt="2025-05-22T01:28:16.194" v="1056" actId="121"/>
@@ -559,14 +486,6 @@
             <ac:cxnSpMk id="23" creationId="{74ACF0F3-BF57-0C7C-D042-FF378FCAA399}"/>
           </ac:cxnSpMkLst>
         </pc:cxnChg>
-        <pc:cxnChg chg="add del mod">
-          <ac:chgData name="Jason Chen" userId="ad652ca3-8ddd-474a-8ac5-da1049da0a80" providerId="ADAL" clId="{5D971BBD-9865-41A7-A526-B0C275857285}" dt="2025-05-22T01:26:28.138" v="1027" actId="478"/>
-          <ac:cxnSpMkLst>
-            <pc:docMk/>
-            <pc:sldMk cId="1797865909" sldId="258"/>
-            <ac:cxnSpMk id="27" creationId="{12176E3D-BF69-E7D2-4E5E-7F8BC50627E1}"/>
-          </ac:cxnSpMkLst>
-        </pc:cxnChg>
         <pc:cxnChg chg="add mod">
           <ac:chgData name="Jason Chen" userId="ad652ca3-8ddd-474a-8ac5-da1049da0a80" providerId="ADAL" clId="{5D971BBD-9865-41A7-A526-B0C275857285}" dt="2025-05-22T01:24:23.234" v="987" actId="14100"/>
           <ac:cxnSpMkLst>
@@ -623,14 +542,6 @@
             <ac:cxnSpMk id="105" creationId="{4161EAC5-0B62-3DD8-BE59-9D030920CD07}"/>
           </ac:cxnSpMkLst>
         </pc:cxnChg>
-        <pc:cxnChg chg="add del mod">
-          <ac:chgData name="Jason Chen" userId="ad652ca3-8ddd-474a-8ac5-da1049da0a80" providerId="ADAL" clId="{5D971BBD-9865-41A7-A526-B0C275857285}" dt="2025-05-21T19:02:15.624" v="613" actId="478"/>
-          <ac:cxnSpMkLst>
-            <pc:docMk/>
-            <pc:sldMk cId="1797865909" sldId="258"/>
-            <ac:cxnSpMk id="109" creationId="{70160127-1CD2-B37C-5B4F-9DA168C4A822}"/>
-          </ac:cxnSpMkLst>
-        </pc:cxnChg>
         <pc:cxnChg chg="add mod">
           <ac:chgData name="Jason Chen" userId="ad652ca3-8ddd-474a-8ac5-da1049da0a80" providerId="ADAL" clId="{5D971BBD-9865-41A7-A526-B0C275857285}" dt="2025-05-22T01:19:46.744" v="902" actId="1076"/>
           <ac:cxnSpMkLst>
@@ -678,36 +589,12 @@
             <ac:spMk id="2" creationId="{F0D0CC2D-55CB-4D29-D175-EB0D8C16A5F2}"/>
           </ac:spMkLst>
         </pc:spChg>
-        <pc:spChg chg="del mod">
-          <ac:chgData name="Jason Chen" userId="ad652ca3-8ddd-474a-8ac5-da1049da0a80" providerId="ADAL" clId="{5D971BBD-9865-41A7-A526-B0C275857285}" dt="2025-05-22T02:11:26.977" v="1252" actId="478"/>
-          <ac:spMkLst>
-            <pc:docMk/>
-            <pc:sldMk cId="3746183995" sldId="259"/>
-            <ac:spMk id="3" creationId="{248E017C-F92E-E760-FF2B-CBE6BD0312BE}"/>
-          </ac:spMkLst>
-        </pc:spChg>
-        <pc:spChg chg="add del mod">
-          <ac:chgData name="Jason Chen" userId="ad652ca3-8ddd-474a-8ac5-da1049da0a80" providerId="ADAL" clId="{5D971BBD-9865-41A7-A526-B0C275857285}" dt="2025-05-22T02:13:06.714" v="1278" actId="478"/>
-          <ac:spMkLst>
-            <pc:docMk/>
-            <pc:sldMk cId="3746183995" sldId="259"/>
-            <ac:spMk id="4" creationId="{29FFD69C-A115-39D9-7E25-7F0A22108B74}"/>
-          </ac:spMkLst>
-        </pc:spChg>
         <pc:spChg chg="add mod">
           <ac:chgData name="Jason Chen" userId="ad652ca3-8ddd-474a-8ac5-da1049da0a80" providerId="ADAL" clId="{5D971BBD-9865-41A7-A526-B0C275857285}" dt="2025-05-22T02:15:34.445" v="1398" actId="113"/>
           <ac:spMkLst>
             <pc:docMk/>
             <pc:sldMk cId="3746183995" sldId="259"/>
             <ac:spMk id="6" creationId="{5A3A6DD9-9353-44CF-D64D-516BA3AE55C0}"/>
-          </ac:spMkLst>
-        </pc:spChg>
-        <pc:spChg chg="add del mod">
-          <ac:chgData name="Jason Chen" userId="ad652ca3-8ddd-474a-8ac5-da1049da0a80" providerId="ADAL" clId="{5D971BBD-9865-41A7-A526-B0C275857285}" dt="2025-05-22T02:14:04.166" v="1330"/>
-          <ac:spMkLst>
-            <pc:docMk/>
-            <pc:sldMk cId="3746183995" sldId="259"/>
-            <ac:spMk id="10" creationId="{6A038EB0-CE49-C39E-F7E1-06480ABECB3D}"/>
           </ac:spMkLst>
         </pc:spChg>
         <pc:spChg chg="add mod">
@@ -734,14 +621,6 @@
             <ac:picMk id="1027" creationId="{E587A7EB-22AB-8DAD-03F3-DE3675C8F7E2}"/>
           </ac:picMkLst>
         </pc:picChg>
-        <pc:cxnChg chg="add del mod">
-          <ac:chgData name="Jason Chen" userId="ad652ca3-8ddd-474a-8ac5-da1049da0a80" providerId="ADAL" clId="{5D971BBD-9865-41A7-A526-B0C275857285}" dt="2025-05-22T02:13:06.714" v="1278" actId="478"/>
-          <ac:cxnSpMkLst>
-            <pc:docMk/>
-            <pc:sldMk cId="3746183995" sldId="259"/>
-            <ac:cxnSpMk id="5" creationId="{9D8CBD3A-2EF0-9E01-954E-55FE3635EED1}"/>
-          </ac:cxnSpMkLst>
-        </pc:cxnChg>
         <pc:cxnChg chg="add mod">
           <ac:chgData name="Jason Chen" userId="ad652ca3-8ddd-474a-8ac5-da1049da0a80" providerId="ADAL" clId="{5D971BBD-9865-41A7-A526-B0C275857285}" dt="2025-05-22T02:15:32.149" v="1397" actId="1076"/>
           <ac:cxnSpMkLst>
@@ -826,14 +705,6 @@
             <ac:spMk id="2" creationId="{EABE2B45-1A72-D76A-D58F-2B621F1BE380}"/>
           </ac:spMkLst>
         </pc:spChg>
-        <pc:spChg chg="del mod">
-          <ac:chgData name="Jason Chen" userId="ad652ca3-8ddd-474a-8ac5-da1049da0a80" providerId="ADAL" clId="{5D971BBD-9865-41A7-A526-B0C275857285}" dt="2025-05-22T02:09:24.340" v="1193" actId="478"/>
-          <ac:spMkLst>
-            <pc:docMk/>
-            <pc:sldMk cId="437212802" sldId="263"/>
-            <ac:spMk id="3" creationId="{0020147E-5D39-6FD3-BB90-5A6404F2354C}"/>
-          </ac:spMkLst>
-        </pc:spChg>
         <pc:spChg chg="add mod">
           <ac:chgData name="Jason Chen" userId="ad652ca3-8ddd-474a-8ac5-da1049da0a80" providerId="ADAL" clId="{5D971BBD-9865-41A7-A526-B0C275857285}" dt="2025-05-22T02:15:54.198" v="1403" actId="1076"/>
           <ac:spMkLst>
@@ -873,14 +744,6 @@
           <pc:docMk/>
           <pc:sldMk cId="2086419277" sldId="264"/>
         </pc:sldMkLst>
-        <pc:spChg chg="mod">
-          <ac:chgData name="Jason Chen" userId="ad652ca3-8ddd-474a-8ac5-da1049da0a80" providerId="ADAL" clId="{5D971BBD-9865-41A7-A526-B0C275857285}" dt="2025-05-22T01:58:13.537" v="1082" actId="20577"/>
-          <ac:spMkLst>
-            <pc:docMk/>
-            <pc:sldMk cId="2086419277" sldId="264"/>
-            <ac:spMk id="2" creationId="{B5FC189E-3FF2-2B01-45DC-7EA7F6BB2F73}"/>
-          </ac:spMkLst>
-        </pc:spChg>
       </pc:sldChg>
       <pc:sldChg chg="addSp modSp new mod">
         <pc:chgData name="Jason Chen" userId="ad652ca3-8ddd-474a-8ac5-da1049da0a80" providerId="ADAL" clId="{5D971BBD-9865-41A7-A526-B0C275857285}" dt="2025-05-22T02:03:48.524" v="1125" actId="1076"/>
@@ -1089,7 +952,7 @@
           <a:p>
             <a:fld id="{A871A988-053F-497F-B912-C9E184DD9C59}" type="datetimeFigureOut">
               <a:rPr lang="en-US" smtClean="0"/>
-              <a:t>5/21/2025</a:t>
+              <a:t>6/4/2025</a:t>
             </a:fld>
             <a:endParaRPr lang="en-US"/>
           </a:p>
@@ -1287,7 +1150,7 @@
           <a:p>
             <a:fld id="{A871A988-053F-497F-B912-C9E184DD9C59}" type="datetimeFigureOut">
               <a:rPr lang="en-US" smtClean="0"/>
-              <a:t>5/21/2025</a:t>
+              <a:t>6/4/2025</a:t>
             </a:fld>
             <a:endParaRPr lang="en-US"/>
           </a:p>
@@ -1495,7 +1358,7 @@
           <a:p>
             <a:fld id="{A871A988-053F-497F-B912-C9E184DD9C59}" type="datetimeFigureOut">
               <a:rPr lang="en-US" smtClean="0"/>
-              <a:t>5/21/2025</a:t>
+              <a:t>6/4/2025</a:t>
             </a:fld>
             <a:endParaRPr lang="en-US"/>
           </a:p>
@@ -1693,7 +1556,7 @@
           <a:p>
             <a:fld id="{A871A988-053F-497F-B912-C9E184DD9C59}" type="datetimeFigureOut">
               <a:rPr lang="en-US" smtClean="0"/>
-              <a:t>5/21/2025</a:t>
+              <a:t>6/4/2025</a:t>
             </a:fld>
             <a:endParaRPr lang="en-US"/>
           </a:p>
@@ -1968,7 +1831,7 @@
           <a:p>
             <a:fld id="{A871A988-053F-497F-B912-C9E184DD9C59}" type="datetimeFigureOut">
               <a:rPr lang="en-US" smtClean="0"/>
-              <a:t>5/21/2025</a:t>
+              <a:t>6/4/2025</a:t>
             </a:fld>
             <a:endParaRPr lang="en-US"/>
           </a:p>
@@ -2233,7 +2096,7 @@
           <a:p>
             <a:fld id="{A871A988-053F-497F-B912-C9E184DD9C59}" type="datetimeFigureOut">
               <a:rPr lang="en-US" smtClean="0"/>
-              <a:t>5/21/2025</a:t>
+              <a:t>6/4/2025</a:t>
             </a:fld>
             <a:endParaRPr lang="en-US"/>
           </a:p>
@@ -2645,7 +2508,7 @@
           <a:p>
             <a:fld id="{A871A988-053F-497F-B912-C9E184DD9C59}" type="datetimeFigureOut">
               <a:rPr lang="en-US" smtClean="0"/>
-              <a:t>5/21/2025</a:t>
+              <a:t>6/4/2025</a:t>
             </a:fld>
             <a:endParaRPr lang="en-US"/>
           </a:p>
@@ -2786,7 +2649,7 @@
           <a:p>
             <a:fld id="{A871A988-053F-497F-B912-C9E184DD9C59}" type="datetimeFigureOut">
               <a:rPr lang="en-US" smtClean="0"/>
-              <a:t>5/21/2025</a:t>
+              <a:t>6/4/2025</a:t>
             </a:fld>
             <a:endParaRPr lang="en-US"/>
           </a:p>
@@ -2899,7 +2762,7 @@
           <a:p>
             <a:fld id="{A871A988-053F-497F-B912-C9E184DD9C59}" type="datetimeFigureOut">
               <a:rPr lang="en-US" smtClean="0"/>
-              <a:t>5/21/2025</a:t>
+              <a:t>6/4/2025</a:t>
             </a:fld>
             <a:endParaRPr lang="en-US"/>
           </a:p>
@@ -3210,7 +3073,7 @@
           <a:p>
             <a:fld id="{A871A988-053F-497F-B912-C9E184DD9C59}" type="datetimeFigureOut">
               <a:rPr lang="en-US" smtClean="0"/>
-              <a:t>5/21/2025</a:t>
+              <a:t>6/4/2025</a:t>
             </a:fld>
             <a:endParaRPr lang="en-US"/>
           </a:p>
@@ -3498,7 +3361,7 @@
           <a:p>
             <a:fld id="{A871A988-053F-497F-B912-C9E184DD9C59}" type="datetimeFigureOut">
               <a:rPr lang="en-US" smtClean="0"/>
-              <a:t>5/21/2025</a:t>
+              <a:t>6/4/2025</a:t>
             </a:fld>
             <a:endParaRPr lang="en-US"/>
           </a:p>
@@ -3739,7 +3602,7 @@
           <a:p>
             <a:fld id="{A871A988-053F-497F-B912-C9E184DD9C59}" type="datetimeFigureOut">
               <a:rPr lang="en-US" smtClean="0"/>
-              <a:t>5/21/2025</a:t>
+              <a:t>6/4/2025</a:t>
             </a:fld>
             <a:endParaRPr lang="en-US"/>
           </a:p>
@@ -6758,6 +6621,446 @@
 </p:sld>
 </file>
 
+<file path=ppt/slides/slide8.xml><?xml version="1.0" encoding="utf-8"?>
+<p:sld xmlns:a="http://schemas.openxmlformats.org/drawingml/2006/main" xmlns:r="http://schemas.openxmlformats.org/officeDocument/2006/relationships" xmlns:p="http://schemas.openxmlformats.org/presentationml/2006/main">
+  <p:cSld>
+    <p:spTree>
+      <p:nvGrpSpPr>
+        <p:cNvPr id="1" name=""/>
+        <p:cNvGrpSpPr/>
+        <p:nvPr/>
+      </p:nvGrpSpPr>
+      <p:grpSpPr>
+        <a:xfrm>
+          <a:off x="0" y="0"/>
+          <a:ext cx="0" cy="0"/>
+          <a:chOff x="0" y="0"/>
+          <a:chExt cx="0" cy="0"/>
+        </a:xfrm>
+      </p:grpSpPr>
+      <p:sp>
+        <p:nvSpPr>
+          <p:cNvPr id="2" name="Title 1">
+            <a:extLst>
+              <a:ext uri="{FF2B5EF4-FFF2-40B4-BE49-F238E27FC236}">
+                <a16:creationId xmlns:a16="http://schemas.microsoft.com/office/drawing/2014/main" id="{DE1B89B4-5B3D-0643-BDEE-5F54CA4EE2EE}"/>
+              </a:ext>
+            </a:extLst>
+          </p:cNvPr>
+          <p:cNvSpPr>
+            <a:spLocks noGrp="1"/>
+          </p:cNvSpPr>
+          <p:nvPr>
+            <p:ph type="title"/>
+          </p:nvPr>
+        </p:nvSpPr>
+        <p:spPr/>
+        <p:txBody>
+          <a:bodyPr/>
+          <a:lstStyle/>
+          <a:p>
+            <a:r>
+              <a:rPr lang="en-US" dirty="0"/>
+              <a:t>PTC Assembly Video</a:t>
+            </a:r>
+          </a:p>
+        </p:txBody>
+      </p:sp>
+      <p:pic>
+        <p:nvPicPr>
+          <p:cNvPr id="4" name="Online Media 3" title="Testing Chamber Assembly w Subtitles">
+            <a:hlinkClick r:id="" action="ppaction://media"/>
+            <a:extLst>
+              <a:ext uri="{FF2B5EF4-FFF2-40B4-BE49-F238E27FC236}">
+                <a16:creationId xmlns:a16="http://schemas.microsoft.com/office/drawing/2014/main" id="{69EB121A-51C7-D7E9-C237-A9C100B171E9}"/>
+              </a:ext>
+            </a:extLst>
+          </p:cNvPr>
+          <p:cNvPicPr>
+            <a:picLocks noGrp="1" noRot="1" noChangeAspect="1"/>
+          </p:cNvPicPr>
+          <p:nvPr>
+            <p:ph idx="1"/>
+            <a:videoFile r:link="rId1"/>
+          </p:nvPr>
+        </p:nvPicPr>
+        <p:blipFill>
+          <a:blip r:embed="rId3"/>
+          <a:stretch>
+            <a:fillRect/>
+          </a:stretch>
+        </p:blipFill>
+        <p:spPr>
+          <a:xfrm>
+            <a:off x="1872360" y="2084965"/>
+            <a:ext cx="8447279" cy="4773035"/>
+          </a:xfrm>
+          <a:prstGeom prst="rect">
+            <a:avLst/>
+          </a:prstGeom>
+        </p:spPr>
+      </p:pic>
+      <p:sp>
+        <p:nvSpPr>
+          <p:cNvPr id="5" name="Content Placeholder 2">
+            <a:extLst>
+              <a:ext uri="{FF2B5EF4-FFF2-40B4-BE49-F238E27FC236}">
+                <a16:creationId xmlns:a16="http://schemas.microsoft.com/office/drawing/2014/main" id="{A8310154-AB87-CD2F-41DF-CDD3C3C67B45}"/>
+              </a:ext>
+            </a:extLst>
+          </p:cNvPr>
+          <p:cNvSpPr txBox="1">
+            <a:spLocks/>
+          </p:cNvSpPr>
+          <p:nvPr/>
+        </p:nvSpPr>
+        <p:spPr>
+          <a:xfrm>
+            <a:off x="838200" y="1413164"/>
+            <a:ext cx="10515600" cy="4773035"/>
+          </a:xfrm>
+          <a:prstGeom prst="rect">
+            <a:avLst/>
+          </a:prstGeom>
+        </p:spPr>
+        <p:txBody>
+          <a:bodyPr vert="horz" lIns="91440" tIns="45720" rIns="91440" bIns="45720" rtlCol="0">
+            <a:normAutofit/>
+          </a:bodyPr>
+          <a:lstStyle>
+            <a:lvl1pPr marL="228600" indent="-228600" algn="l" defTabSz="914400" rtl="0" eaLnBrk="1" latinLnBrk="0" hangingPunct="1">
+              <a:lnSpc>
+                <a:spcPct val="90000"/>
+              </a:lnSpc>
+              <a:spcBef>
+                <a:spcPts val="1000"/>
+              </a:spcBef>
+              <a:buFont typeface="Arial" panose="020B0604020202020204" pitchFamily="34" charset="0"/>
+              <a:buChar char="•"/>
+              <a:defRPr sz="2800" kern="1200">
+                <a:solidFill>
+                  <a:schemeClr val="tx1"/>
+                </a:solidFill>
+                <a:latin typeface="+mn-lt"/>
+                <a:ea typeface="+mn-ea"/>
+                <a:cs typeface="+mn-cs"/>
+              </a:defRPr>
+            </a:lvl1pPr>
+            <a:lvl2pPr marL="685800" indent="-228600" algn="l" defTabSz="914400" rtl="0" eaLnBrk="1" latinLnBrk="0" hangingPunct="1">
+              <a:lnSpc>
+                <a:spcPct val="90000"/>
+              </a:lnSpc>
+              <a:spcBef>
+                <a:spcPts val="500"/>
+              </a:spcBef>
+              <a:buFont typeface="Arial" panose="020B0604020202020204" pitchFamily="34" charset="0"/>
+              <a:buChar char="•"/>
+              <a:defRPr sz="2400" kern="1200">
+                <a:solidFill>
+                  <a:schemeClr val="tx1"/>
+                </a:solidFill>
+                <a:latin typeface="+mn-lt"/>
+                <a:ea typeface="+mn-ea"/>
+                <a:cs typeface="+mn-cs"/>
+              </a:defRPr>
+            </a:lvl2pPr>
+            <a:lvl3pPr marL="1143000" indent="-228600" algn="l" defTabSz="914400" rtl="0" eaLnBrk="1" latinLnBrk="0" hangingPunct="1">
+              <a:lnSpc>
+                <a:spcPct val="90000"/>
+              </a:lnSpc>
+              <a:spcBef>
+                <a:spcPts val="500"/>
+              </a:spcBef>
+              <a:buFont typeface="Arial" panose="020B0604020202020204" pitchFamily="34" charset="0"/>
+              <a:buChar char="•"/>
+              <a:defRPr sz="2000" kern="1200">
+                <a:solidFill>
+                  <a:schemeClr val="tx1"/>
+                </a:solidFill>
+                <a:latin typeface="+mn-lt"/>
+                <a:ea typeface="+mn-ea"/>
+                <a:cs typeface="+mn-cs"/>
+              </a:defRPr>
+            </a:lvl3pPr>
+            <a:lvl4pPr marL="1600200" indent="-228600" algn="l" defTabSz="914400" rtl="0" eaLnBrk="1" latinLnBrk="0" hangingPunct="1">
+              <a:lnSpc>
+                <a:spcPct val="90000"/>
+              </a:lnSpc>
+              <a:spcBef>
+                <a:spcPts val="500"/>
+              </a:spcBef>
+              <a:buFont typeface="Arial" panose="020B0604020202020204" pitchFamily="34" charset="0"/>
+              <a:buChar char="•"/>
+              <a:defRPr sz="1800" kern="1200">
+                <a:solidFill>
+                  <a:schemeClr val="tx1"/>
+                </a:solidFill>
+                <a:latin typeface="+mn-lt"/>
+                <a:ea typeface="+mn-ea"/>
+                <a:cs typeface="+mn-cs"/>
+              </a:defRPr>
+            </a:lvl4pPr>
+            <a:lvl5pPr marL="2057400" indent="-228600" algn="l" defTabSz="914400" rtl="0" eaLnBrk="1" latinLnBrk="0" hangingPunct="1">
+              <a:lnSpc>
+                <a:spcPct val="90000"/>
+              </a:lnSpc>
+              <a:spcBef>
+                <a:spcPts val="500"/>
+              </a:spcBef>
+              <a:buFont typeface="Arial" panose="020B0604020202020204" pitchFamily="34" charset="0"/>
+              <a:buChar char="•"/>
+              <a:defRPr sz="1800" kern="1200">
+                <a:solidFill>
+                  <a:schemeClr val="tx1"/>
+                </a:solidFill>
+                <a:latin typeface="+mn-lt"/>
+                <a:ea typeface="+mn-ea"/>
+                <a:cs typeface="+mn-cs"/>
+              </a:defRPr>
+            </a:lvl5pPr>
+            <a:lvl6pPr marL="2514600" indent="-228600" algn="l" defTabSz="914400" rtl="0" eaLnBrk="1" latinLnBrk="0" hangingPunct="1">
+              <a:lnSpc>
+                <a:spcPct val="90000"/>
+              </a:lnSpc>
+              <a:spcBef>
+                <a:spcPts val="500"/>
+              </a:spcBef>
+              <a:buFont typeface="Arial" panose="020B0604020202020204" pitchFamily="34" charset="0"/>
+              <a:buChar char="•"/>
+              <a:defRPr sz="1800" kern="1200">
+                <a:solidFill>
+                  <a:schemeClr val="tx1"/>
+                </a:solidFill>
+                <a:latin typeface="+mn-lt"/>
+                <a:ea typeface="+mn-ea"/>
+                <a:cs typeface="+mn-cs"/>
+              </a:defRPr>
+            </a:lvl6pPr>
+            <a:lvl7pPr marL="2971800" indent="-228600" algn="l" defTabSz="914400" rtl="0" eaLnBrk="1" latinLnBrk="0" hangingPunct="1">
+              <a:lnSpc>
+                <a:spcPct val="90000"/>
+              </a:lnSpc>
+              <a:spcBef>
+                <a:spcPts val="500"/>
+              </a:spcBef>
+              <a:buFont typeface="Arial" panose="020B0604020202020204" pitchFamily="34" charset="0"/>
+              <a:buChar char="•"/>
+              <a:defRPr sz="1800" kern="1200">
+                <a:solidFill>
+                  <a:schemeClr val="tx1"/>
+                </a:solidFill>
+                <a:latin typeface="+mn-lt"/>
+                <a:ea typeface="+mn-ea"/>
+                <a:cs typeface="+mn-cs"/>
+              </a:defRPr>
+            </a:lvl7pPr>
+            <a:lvl8pPr marL="3429000" indent="-228600" algn="l" defTabSz="914400" rtl="0" eaLnBrk="1" latinLnBrk="0" hangingPunct="1">
+              <a:lnSpc>
+                <a:spcPct val="90000"/>
+              </a:lnSpc>
+              <a:spcBef>
+                <a:spcPts val="500"/>
+              </a:spcBef>
+              <a:buFont typeface="Arial" panose="020B0604020202020204" pitchFamily="34" charset="0"/>
+              <a:buChar char="•"/>
+              <a:defRPr sz="1800" kern="1200">
+                <a:solidFill>
+                  <a:schemeClr val="tx1"/>
+                </a:solidFill>
+                <a:latin typeface="+mn-lt"/>
+                <a:ea typeface="+mn-ea"/>
+                <a:cs typeface="+mn-cs"/>
+              </a:defRPr>
+            </a:lvl8pPr>
+            <a:lvl9pPr marL="3886200" indent="-228600" algn="l" defTabSz="914400" rtl="0" eaLnBrk="1" latinLnBrk="0" hangingPunct="1">
+              <a:lnSpc>
+                <a:spcPct val="90000"/>
+              </a:lnSpc>
+              <a:spcBef>
+                <a:spcPts val="500"/>
+              </a:spcBef>
+              <a:buFont typeface="Arial" panose="020B0604020202020204" pitchFamily="34" charset="0"/>
+              <a:buChar char="•"/>
+              <a:defRPr sz="1800" kern="1200">
+                <a:solidFill>
+                  <a:schemeClr val="tx1"/>
+                </a:solidFill>
+                <a:latin typeface="+mn-lt"/>
+                <a:ea typeface="+mn-ea"/>
+                <a:cs typeface="+mn-cs"/>
+              </a:defRPr>
+            </a:lvl9pPr>
+          </a:lstStyle>
+          <a:p>
+            <a:r>
+              <a:rPr lang="en-US" sz="1600" dirty="0"/>
+              <a:t>Protocol by Tri Quang, Ph.D., Michele </a:t>
+            </a:r>
+            <a:r>
+              <a:rPr lang="en-US" sz="1600" dirty="0" err="1"/>
+              <a:t>Kaluzienski</a:t>
+            </a:r>
+            <a:r>
+              <a:rPr lang="en-US" sz="1600" dirty="0"/>
+              <a:t>, Surabhi Singh, and Jason Chen</a:t>
+            </a:r>
+          </a:p>
+          <a:p>
+            <a:r>
+              <a:rPr lang="en-US" sz="1600" dirty="0"/>
+              <a:t>Filming and editing by Talya Simcox</a:t>
+            </a:r>
+          </a:p>
+        </p:txBody>
+      </p:sp>
+    </p:spTree>
+    <p:extLst>
+      <p:ext uri="{BB962C8B-B14F-4D97-AF65-F5344CB8AC3E}">
+        <p14:creationId xmlns:p14="http://schemas.microsoft.com/office/powerpoint/2010/main" val="645902538"/>
+      </p:ext>
+    </p:extLst>
+  </p:cSld>
+  <p:clrMapOvr>
+    <a:masterClrMapping/>
+  </p:clrMapOvr>
+  <p:timing>
+    <p:tnLst>
+      <p:par>
+        <p:cTn id="1" dur="indefinite" restart="never" nodeType="tmRoot">
+          <p:childTnLst>
+            <p:seq concurrent="1" nextAc="seek">
+              <p:cTn id="2" dur="indefinite" nodeType="mainSeq">
+                <p:childTnLst>
+                  <p:par>
+                    <p:cTn id="3" fill="hold">
+                      <p:stCondLst>
+                        <p:cond delay="indefinite"/>
+                      </p:stCondLst>
+                      <p:childTnLst>
+                        <p:par>
+                          <p:cTn id="4" fill="hold">
+                            <p:stCondLst>
+                              <p:cond delay="0"/>
+                            </p:stCondLst>
+                            <p:childTnLst>
+                              <p:par>
+                                <p:cTn id="5" presetID="1" presetClass="mediacall" presetSubtype="0" fill="hold" nodeType="clickEffect">
+                                  <p:stCondLst>
+                                    <p:cond delay="0"/>
+                                  </p:stCondLst>
+                                  <p:childTnLst>
+                                    <p:cmd type="call" cmd="playFrom(0.0)">
+                                      <p:cBhvr>
+                                        <p:cTn id="6" dur="1" fill="hold"/>
+                                        <p:tgtEl>
+                                          <p:spTgt spid="4"/>
+                                        </p:tgtEl>
+                                      </p:cBhvr>
+                                    </p:cmd>
+                                  </p:childTnLst>
+                                </p:cTn>
+                              </p:par>
+                            </p:childTnLst>
+                          </p:cTn>
+                        </p:par>
+                      </p:childTnLst>
+                    </p:cTn>
+                  </p:par>
+                </p:childTnLst>
+              </p:cTn>
+              <p:prevCondLst>
+                <p:cond evt="onPrev" delay="0">
+                  <p:tgtEl>
+                    <p:sldTgt/>
+                  </p:tgtEl>
+                </p:cond>
+              </p:prevCondLst>
+              <p:nextCondLst>
+                <p:cond evt="onNext" delay="0">
+                  <p:tgtEl>
+                    <p:sldTgt/>
+                  </p:tgtEl>
+                </p:cond>
+              </p:nextCondLst>
+            </p:seq>
+            <p:video>
+              <p:cMediaNode vol="80000">
+                <p:cTn id="7" fill="hold" display="0">
+                  <p:stCondLst>
+                    <p:cond delay="indefinite"/>
+                  </p:stCondLst>
+                </p:cTn>
+                <p:tgtEl>
+                  <p:spTgt spid="4"/>
+                </p:tgtEl>
+              </p:cMediaNode>
+            </p:video>
+            <p:seq concurrent="1" nextAc="seek">
+              <p:cTn id="8" restart="whenNotActive" fill="hold" evtFilter="cancelBubble" nodeType="interactiveSeq">
+                <p:stCondLst>
+                  <p:cond evt="onClick" delay="0">
+                    <p:tgtEl>
+                      <p:spTgt spid="4"/>
+                    </p:tgtEl>
+                  </p:cond>
+                </p:stCondLst>
+                <p:endSync evt="end" delay="0">
+                  <p:rtn val="all"/>
+                </p:endSync>
+                <p:childTnLst>
+                  <p:par>
+                    <p:cTn id="9" fill="hold">
+                      <p:stCondLst>
+                        <p:cond delay="0"/>
+                      </p:stCondLst>
+                      <p:childTnLst>
+                        <p:par>
+                          <p:cTn id="10" fill="hold">
+                            <p:stCondLst>
+                              <p:cond delay="0"/>
+                            </p:stCondLst>
+                            <p:childTnLst>
+                              <p:par>
+                                <p:cTn id="11" presetID="2" presetClass="mediacall" presetSubtype="0" fill="hold" nodeType="clickEffect">
+                                  <p:stCondLst>
+                                    <p:cond delay="0"/>
+                                  </p:stCondLst>
+                                  <p:childTnLst>
+                                    <p:cmd type="call" cmd="togglePause">
+                                      <p:cBhvr>
+                                        <p:cTn id="12" dur="1" fill="hold"/>
+                                        <p:tgtEl>
+                                          <p:spTgt spid="4"/>
+                                        </p:tgtEl>
+                                      </p:cBhvr>
+                                    </p:cmd>
+                                  </p:childTnLst>
+                                </p:cTn>
+                              </p:par>
+                            </p:childTnLst>
+                          </p:cTn>
+                        </p:par>
+                      </p:childTnLst>
+                    </p:cTn>
+                  </p:par>
+                </p:childTnLst>
+              </p:cTn>
+              <p:nextCondLst>
+                <p:cond evt="onClick" delay="0">
+                  <p:tgtEl>
+                    <p:spTgt spid="4"/>
+                  </p:tgtEl>
+                </p:cond>
+              </p:nextCondLst>
+            </p:seq>
+          </p:childTnLst>
+        </p:cTn>
+      </p:par>
+    </p:tnLst>
+  </p:timing>
+</p:sld>
+</file>
+
 <file path=ppt/theme/theme1.xml><?xml version="1.0" encoding="utf-8"?>
 <a:theme xmlns:a="http://schemas.openxmlformats.org/drawingml/2006/main" name="Office Theme">
   <a:themeElements>

</xml_diff>